<commit_message>
docs: diagrama sobre o modelo AWS do Lucidchart, com ícones
Pedido da professora em 29/10: o diagrama passa a usar o modelo
"Estrutura horizontal AWS (2019)" do Lucidchart, com o ícone oficial de
cada serviço e as setas do caminho de um relato numeradas de 1 a 5. A
passageira entra no desenho e na legenda. O documento vai à versão 1.4,
e a apresentação da Sprint 2 recebe o diagrama novo no slide 8.

Co-Authored-By: Claude Opus 5.5 <noreply@anthropic.com>
</commit_message>
<xml_diff>
--- a/apresentacoes/sprint-2.pptx
+++ b/apresentacoes/sprint-2.pptx
@@ -118,23 +118,23 @@
   <p:extLst>
     <p:ext uri="{521415D9-36F7-43E2-AB2F-B90AF26B5E84}">
       <p14:sectionLst xmlns:p14="http://schemas.microsoft.com/office/powerpoint/2010/main">
-        <p14:section name="Abertura" id="{7dd3a05e-5b69-56b8-f301-d45b3d83acde}">
+        <p14:section name="Abertura" id="{b596ba42-471b-0713-a8e3-99047f2f1bad}">
           <p14:sldIdLst>
             <p14:sldId id="256"/>
           </p14:sldIdLst>
         </p14:section>
-        <p14:section name="Cenário" id="{17190b6d-1e37-4796-51d0-05feb252fd83}">
+        <p14:section name="Cenário" id="{8c64219f-c772-be56-fb2d-d5948cfd91d3}">
           <p14:sldIdLst>
             <p14:sldId id="257"/>
           </p14:sldIdLst>
         </p14:section>
-        <p14:section name="Qualidade" id="{e30e4312-0a8b-ee1c-11ff-b00b0e0098f8}">
+        <p14:section name="Qualidade" id="{57da55e8-bae2-5265-9c28-1bf6c819e222}">
           <p14:sldIdLst>
             <p14:sldId id="258"/>
             <p14:sldId id="259"/>
           </p14:sldIdLst>
         </p14:section>
-        <p14:section name="Arquitetura" id="{1144dc19-7468-66ad-623a-c9e0e36554ba}">
+        <p14:section name="Arquitetura" id="{36efce1c-739e-79a2-913c-81b48891a216}">
           <p14:sldIdLst>
             <p14:sldId id="260"/>
             <p14:sldId id="261"/>
@@ -143,13 +143,13 @@
             <p14:sldId id="264"/>
           </p14:sldIdLst>
         </p14:section>
-        <p14:section name="Backlog e recorte" id="{00abf6dc-7f0f-2331-9254-678943bc98e6}">
+        <p14:section name="Backlog e recorte" id="{d2eae516-a1fb-4c61-9bf9-3befe975fd4c}">
           <p14:sldIdLst>
             <p14:sldId id="265"/>
             <p14:sldId id="266"/>
           </p14:sldIdLst>
         </p14:section>
-        <p14:section name="Fecho" id="{fc309304-88fa-8aec-2005-d2bfc327bb81}">
+        <p14:section name="Fecho" id="{cba899a6-8ad5-9366-68c9-0fb734034589}">
           <p14:sldIdLst>
             <p14:sldId id="267"/>
           </p14:sldIdLst>
@@ -1438,7 +1438,7 @@
           <a:p>
             <a:r>
               <a:rPr lang="en-US" dirty="0"/>
-              <a:t>O diagrama, feito no Lucidchart: três camadas e o apoio, com o IAM e o CloudWatch. São dez caixas, e toda caixa tem um requisito na legenda. Se uma caixa cair: sem a função registrar, nenhum relato novo entra, mas a consulta continua; sem a consultar, a passageira não vê a lista, mas nada se perde; sem a tabela, nada funciona; sem o bucket, o relato falha antes de gravar, porque a foto vai primeiro; sem o CloudWatch, tudo funciona, mas perde-se a prova do RF-05.</a:t>
+              <a:t>O diagrama, feito no Lucidchart sobre o modelo AWS, com o ícone oficial de cada serviço: três camadas e o apoio, com o IAM e o CloudWatch. As setas de 1 a 5 seguem um relato: o navegador envia ao API Gateway, que chama a função registrar; ela grava primeiro a foto e depois o relato; e a consultar lê os últimos 30 dias. Se uma caixa cair: sem a função registrar, nenhum relato novo entra, mas a consulta continua; sem a consultar, a passageira não vê a lista, mas nada se perde; sem a tabela, nada funciona; sem o bucket, o relato falha antes de gravar, porque a foto vai primeiro; sem o CloudWatch, tudo funciona, mas perde-se a prova do RF-05.</a:t>
             </a:r>
             <a:endParaRPr lang="en-US" dirty="0"/>
           </a:p>
@@ -10589,12 +10589,12 @@
         </p:nvSpPr>
         <p:spPr>
           <a:xfrm>
-            <a:off x="4653316" y="1051560"/>
-            <a:ext cx="6730964" cy="5166360"/>
+            <a:off x="813816" y="2057400"/>
+            <a:ext cx="8259184" cy="4343400"/>
           </a:xfrm>
           <a:prstGeom prst="roundRect">
             <a:avLst>
-              <a:gd name="adj" fmla="val 1416"/>
+              <a:gd name="adj" fmla="val 1684"/>
             </a:avLst>
           </a:prstGeom>
           <a:solidFill>
@@ -10610,7 +10610,7 @@
       </p:sp>
       <p:pic>
         <p:nvPicPr>
-          <p:cNvPr id="8" name="Diagrama" descr="Diagrama de arquitetura do CPTM SOS: navegador e site no S3; API Gateway e as funções registrar, confirmar e consultar; tabela no DynamoDB e fotos no S3; IAM e CloudWatch Logs como apoio.">    </p:cNvPr>
+          <p:cNvPr id="8" name="Diagrama" descr="Diagrama de arquitetura AWS do CPTM SOS: a passageira usa o navegador; na nuvem AWS, o site no S3, o API Gateway e as funções registrar, confirmar e consultar, a tabela no DynamoDB e as fotos no S3; IAM e CloudWatch como apoio. Setas de 1 a 5 seguem o caminho de um relato.">    </p:cNvPr>
           <p:cNvPicPr>
             <a:picLocks noChangeAspect="1"/>
           </p:cNvPicPr>
@@ -10624,8 +10624,8 @@
         </p:blipFill>
         <p:spPr>
           <a:xfrm>
-            <a:off x="4744756" y="1143000"/>
-            <a:ext cx="6548084" cy="4983480"/>
+            <a:off x="905256" y="2148840"/>
+            <a:ext cx="8076304" cy="4160520"/>
           </a:xfrm>
           <a:prstGeom prst="rect">
             <a:avLst/>
@@ -10640,8 +10640,8 @@
         </p:nvSpPr>
         <p:spPr>
           <a:xfrm>
-            <a:off x="813816" y="2148840"/>
-            <a:ext cx="3565180" cy="777240"/>
+            <a:off x="9347320" y="2103120"/>
+            <a:ext cx="2036960" cy="868680"/>
           </a:xfrm>
           <a:prstGeom prst="rect">
             <a:avLst/>
@@ -10657,25 +10657,14 @@
               <a:buNone/>
             </a:pPr>
             <a:r>
-              <a:rPr lang="en-US" sz="1800" b="1" dirty="0">
+              <a:rPr lang="en-US" sz="1600" b="1" dirty="0">
                 <a:solidFill>
                   <a:schemeClr val="tx1"/>
                 </a:solidFill>
               </a:rPr>
-              <a:t>Dez caixas</a:t>
-            </a:r>
-            <a:pPr indent="0" marL="0">
-              <a:buNone/>
-            </a:pPr>
-            <a:r>
-              <a:rPr lang="en-US" sz="1800" dirty="0">
-                <a:solidFill>
-                  <a:schemeClr val="tx1"/>
-                </a:solidFill>
-              </a:rPr>
-              <a:t>, cada uma com um requisito na legenda.</a:t>
-            </a:r>
-            <a:endParaRPr lang="en-US" sz="1800" dirty="0"/>
+              <a:t>Cada ícone tem um requisito na legenda.</a:t>
+            </a:r>
+            <a:endParaRPr lang="en-US" sz="1600" dirty="0"/>
           </a:p>
         </p:txBody>
       </p:sp>
@@ -10687,8 +10676,8 @@
         </p:nvSpPr>
         <p:spPr>
           <a:xfrm>
-            <a:off x="813816" y="3154680"/>
-            <a:ext cx="3565180" cy="274320"/>
+            <a:off x="9347320" y="3154680"/>
+            <a:ext cx="2036960" cy="274320"/>
           </a:xfrm>
           <a:prstGeom prst="rect">
             <a:avLst/>
@@ -10712,7 +10701,7 @@
                 <a:ea typeface="Courier New" pitchFamily="34" charset="-122"/>
                 <a:cs typeface="Courier New" pitchFamily="34" charset="-120"/>
               </a:rPr>
-              <a:t>1 · a ordem</a:t>
+              <a:t>setas 3 e 4</a:t>
             </a:r>
             <a:endParaRPr lang="en-US" sz="1200" dirty="0"/>
           </a:p>
@@ -10726,8 +10715,8 @@
         </p:nvSpPr>
         <p:spPr>
           <a:xfrm>
-            <a:off x="813816" y="3465576"/>
-            <a:ext cx="3565180" cy="658368"/>
+            <a:off x="9347320" y="3447288"/>
+            <a:ext cx="2036960" cy="731520"/>
           </a:xfrm>
           <a:prstGeom prst="rect">
             <a:avLst/>
@@ -10743,14 +10732,14 @@
               <a:buNone/>
             </a:pPr>
             <a:r>
-              <a:rPr lang="en-US" sz="1600" dirty="0">
+              <a:rPr lang="en-US" sz="1500" dirty="0">
                 <a:solidFill>
                   <a:schemeClr val="tx1"/>
                 </a:solidFill>
               </a:rPr>
               <a:t>Foto primeiro, relato depois.</a:t>
             </a:r>
-            <a:endParaRPr lang="en-US" sz="1600" dirty="0"/>
+            <a:endParaRPr lang="en-US" sz="1500" dirty="0"/>
           </a:p>
         </p:txBody>
       </p:sp>
@@ -10762,8 +10751,8 @@
         </p:nvSpPr>
         <p:spPr>
           <a:xfrm>
-            <a:off x="813816" y="4206240"/>
-            <a:ext cx="3565180" cy="274320"/>
+            <a:off x="9347320" y="4206240"/>
+            <a:ext cx="2036960" cy="274320"/>
           </a:xfrm>
           <a:prstGeom prst="rect">
             <a:avLst/>
@@ -10787,7 +10776,7 @@
                 <a:ea typeface="Courier New" pitchFamily="34" charset="-122"/>
                 <a:cs typeface="Courier New" pitchFamily="34" charset="-120"/>
               </a:rPr>
-              <a:t>2 · a separação</a:t>
+              <a:t>a separação</a:t>
             </a:r>
             <a:endParaRPr lang="en-US" sz="1200" dirty="0"/>
           </a:p>
@@ -10801,8 +10790,8 @@
         </p:nvSpPr>
         <p:spPr>
           <a:xfrm>
-            <a:off x="813816" y="4517136"/>
-            <a:ext cx="3565180" cy="658368"/>
+            <a:off x="9347320" y="4498848"/>
+            <a:ext cx="2036960" cy="731520"/>
           </a:xfrm>
           <a:prstGeom prst="rect">
             <a:avLst/>
@@ -10818,14 +10807,14 @@
               <a:buNone/>
             </a:pPr>
             <a:r>
-              <a:rPr lang="en-US" sz="1600" dirty="0">
+              <a:rPr lang="en-US" sz="1500" dirty="0">
                 <a:solidFill>
                   <a:schemeClr val="tx1"/>
                 </a:solidFill>
               </a:rPr>
               <a:t>Nenhuma seta liga o navegador à tabela.</a:t>
             </a:r>
-            <a:endParaRPr lang="en-US" sz="1600" dirty="0"/>
+            <a:endParaRPr lang="en-US" sz="1500" dirty="0"/>
           </a:p>
         </p:txBody>
       </p:sp>
@@ -10837,8 +10826,8 @@
         </p:nvSpPr>
         <p:spPr>
           <a:xfrm>
-            <a:off x="813816" y="5257800"/>
-            <a:ext cx="3565180" cy="274320"/>
+            <a:off x="9347320" y="5257800"/>
+            <a:ext cx="2036960" cy="274320"/>
           </a:xfrm>
           <a:prstGeom prst="rect">
             <a:avLst/>
@@ -10862,7 +10851,7 @@
                 <a:ea typeface="Courier New" pitchFamily="34" charset="-122"/>
                 <a:cs typeface="Courier New" pitchFamily="34" charset="-120"/>
               </a:rPr>
-              <a:t>3 · o tracejado</a:t>
+              <a:t>o tracejado</a:t>
             </a:r>
             <a:endParaRPr lang="en-US" sz="1200" dirty="0"/>
           </a:p>
@@ -10876,8 +10865,8 @@
         </p:nvSpPr>
         <p:spPr>
           <a:xfrm>
-            <a:off x="813816" y="5568696"/>
-            <a:ext cx="3565180" cy="658368"/>
+            <a:off x="9347320" y="5550408"/>
+            <a:ext cx="2036960" cy="731520"/>
           </a:xfrm>
           <a:prstGeom prst="rect">
             <a:avLst/>
@@ -10893,14 +10882,14 @@
               <a:buNone/>
             </a:pPr>
             <a:r>
-              <a:rPr lang="en-US" sz="1600" dirty="0">
+              <a:rPr lang="en-US" sz="1500" dirty="0">
                 <a:solidFill>
                   <a:schemeClr val="tx1"/>
                 </a:solidFill>
               </a:rPr>
               <a:t>Permissão e registro, sem dado da passageira.</a:t>
             </a:r>
-            <a:endParaRPr lang="en-US" sz="1600" dirty="0"/>
+            <a:endParaRPr lang="en-US" sz="1500" dirty="0"/>
           </a:p>
         </p:txBody>
       </p:sp>

</xml_diff>